<commit_message>
M08: Sim-Review umgesetzt (sim_review true, Inhalt aktualisiert)
Co-Authored-By: Claude Opus 4.8 <noreply@anthropic.com>
</commit_message>
<xml_diff>
--- a/protected-downloads/praesentation/M08.pptx
+++ b/protected-downloads/praesentation/M08.pptx
@@ -7702,7 +7702,7 @@
                 </a:solidFill>
                 <a:latin typeface="Arial"/>
               </a:rPr>
-              <a:t>▸  Auf Basis einer vollständigen Projektanalyse eine strukturierte Kreditempfehlung erstellen</a:t>
+              <a:t>▸  Auf Basis einer vollständigen Projektanalyse die zentralen Risikobereiche analysieren und eine strukturierte Kreditempfehlung begründen</a:t>
             </a:r>
           </a:p>
         </p:txBody>
@@ -8113,7 +8113,7 @@
                 </a:solidFill>
                 <a:latin typeface="Consolas"/>
               </a:rPr>
-              <a:t>09:45–10:45 </a:t>
+              <a:t>09:45–10:50 </a:t>
             </a:r>
             <a:r>
               <a:rPr sz="1200" b="1">
@@ -8150,7 +8150,7 @@
                 </a:solidFill>
                 <a:latin typeface="Consolas"/>
               </a:rPr>
-              <a:t>10:45–11:00 </a:t>
+              <a:t>10:50–11:05 </a:t>
             </a:r>
             <a:r>
               <a:rPr sz="1200" b="1">
@@ -8178,7 +8178,7 @@
                 </a:solidFill>
                 <a:latin typeface="Consolas"/>
               </a:rPr>
-              <a:t>11:00–11:45 </a:t>
+              <a:t>11:05–11:50 </a:t>
             </a:r>
             <a:r>
               <a:rPr sz="1200" b="1">
@@ -8215,7 +8215,7 @@
                 </a:solidFill>
                 <a:latin typeface="Consolas"/>
               </a:rPr>
-              <a:t>11:45–12:15 </a:t>
+              <a:t>11:50–12:20 </a:t>
             </a:r>
             <a:r>
               <a:rPr sz="1200" b="1">
@@ -8252,7 +8252,7 @@
                 </a:solidFill>
                 <a:latin typeface="Consolas"/>
               </a:rPr>
-              <a:t>12:15–13:00 </a:t>
+              <a:t>12:20–13:05 </a:t>
             </a:r>
             <a:r>
               <a:rPr sz="1200" b="1">
@@ -8280,7 +8280,7 @@
                 </a:solidFill>
                 <a:latin typeface="Consolas"/>
               </a:rPr>
-              <a:t>13:00–13:45 </a:t>
+              <a:t>13:05–13:50 </a:t>
             </a:r>
             <a:r>
               <a:rPr sz="1200" b="1">
@@ -8317,7 +8317,7 @@
                 </a:solidFill>
                 <a:latin typeface="Consolas"/>
               </a:rPr>
-              <a:t>13:45–15:15 </a:t>
+              <a:t>13:50–15:20 </a:t>
             </a:r>
             <a:r>
               <a:rPr sz="1200" b="1">
@@ -8354,7 +8354,7 @@
                 </a:solidFill>
                 <a:latin typeface="Consolas"/>
               </a:rPr>
-              <a:t>15:15–15:30 </a:t>
+              <a:t>15:20–15:35 </a:t>
             </a:r>
             <a:r>
               <a:rPr sz="1200" b="1">
@@ -8382,7 +8382,7 @@
                 </a:solidFill>
                 <a:latin typeface="Consolas"/>
               </a:rPr>
-              <a:t>15:30–16:30 </a:t>
+              <a:t>15:35–16:30 </a:t>
             </a:r>
             <a:r>
               <a:rPr sz="1200" b="1">

</xml_diff>